<commit_message>
test(pptx): refresh the regenerated smartart build reveal fixture
fixtures:check regenerates the e2e decks and failed CI because the committed smartart-build-reveal deck predates the SmartArt save changes. Regenerated on Linux, as CI does; generation is deterministic.
</commit_message>
<xml_diff>
--- a/e2e/pptx/fixtures/smartart-build-reveal.pptx
+++ b/e2e/pptx/fixtures/smartart-build-reveal.pptx
@@ -288,9 +288,9 @@
           </a:avLst>
         </a:prstGeom>
         <a:solidFill>
-          <a:srgbClr val="4472C4"/>
+          <a:srgbClr xmlns:a="http://schemas.openxmlformats.org/drawingml/2006/main" val="4472C4"/>
         </a:solidFill>
-        <a:ln w="12700">
+        <a:ln xmlns:a="http://schemas.openxmlformats.org/drawingml/2006/main" w="12700">
           <a:solidFill>
             <a:srgbClr val="698ED0"/>
           </a:solidFill>
@@ -349,9 +349,9 @@
           </a:avLst>
         </a:prstGeom>
         <a:solidFill>
-          <a:srgbClr val="ED7D31"/>
+          <a:srgbClr xmlns:a="http://schemas.openxmlformats.org/drawingml/2006/main" val="ED7D31"/>
         </a:solidFill>
-        <a:ln w="12700">
+        <a:ln xmlns:a="http://schemas.openxmlformats.org/drawingml/2006/main" w="12700">
           <a:solidFill>
             <a:srgbClr val="F1975A"/>
           </a:solidFill>
@@ -410,9 +410,9 @@
           </a:avLst>
         </a:prstGeom>
         <a:solidFill>
-          <a:srgbClr val="A5A5A5"/>
+          <a:srgbClr xmlns:a="http://schemas.openxmlformats.org/drawingml/2006/main" val="A5A5A5"/>
         </a:solidFill>
-        <a:ln w="12700">
+        <a:ln xmlns:a="http://schemas.openxmlformats.org/drawingml/2006/main" w="12700">
           <a:solidFill>
             <a:srgbClr val="B7B7B7"/>
           </a:solidFill>

</xml_diff>